<commit_message>
Fix issues from self-review: 12-grade schools, later conditions, gates
- Grades are checked relative to the final school year, so 'two last years'
  and 'not final year' work for both 11- and 12-grade schools (NIS);
  profile gets a 'school has 12 grades' option
- Projection: after grade 11 a student goes to grade 12 (NIS) or university
- ML School 'later' now states the condition (IT/math/tech major)
- IZhO shows a warning about school team selection instead of a bare 'fits'
- UWC and Türkiye plans include a step for the selection round after the
  deadline; unverified 'recommendations' step not added for UWC
- Slide 3: sources described as official sites and open sources
- 33 tests (was 27); offline mode verified with the server stopped

Co-Authored-By: Claude Opus 5.5 <noreply@anthropic.com>
</commit_message>
<xml_diff>
--- a/docs/Maqsat_VentureHack2026_Final.pptx
+++ b/docs/Maqsat_VentureHack2026_Final.pptx
@@ -5359,7 +5359,7 @@
                 </a:solidFill>
                 <a:latin typeface="Arial Black"/>
               </a:rPr>
-              <a:t>27 автотестов: база, условия, план, календарь</a:t>
+              <a:t>33 автотеста: база, условия, план, календарь</a:t>
             </a:r>
           </a:p>
         </p:txBody>
@@ -8460,7 +8460,7 @@
                 </a:solidFill>
                 <a:latin typeface="Arial Black"/>
               </a:rPr>
-              <a:t>Мы сами проверили 13 возможностей для школьников Казахстана на официальных сайтах 26.09.2026.</a:t>
+              <a:t>Мы сами собрали 13 возможностей для школьников Казахстана по официальным сайтам и открытым источникам 26.09.2026.</a:t>
             </a:r>
           </a:p>
         </p:txBody>

</xml_diff>

<commit_message>
Docs and deck: long-term goals, Kazakh UI, CI, source checks
Co-Authored-By: Claude Opus 5.5 <noreply@anthropic.com>
</commit_message>
<xml_diff>
--- a/docs/Maqsat_VentureHack2026_Final.pptx
+++ b/docs/Maqsat_VentureHack2026_Final.pptx
@@ -6245,7 +6245,24 @@
                 </a:solidFill>
                 <a:latin typeface="Arial Black"/>
               </a:rPr>
-              <a:t>37 автотестов: база, условия, план, календарь</a:t>
+              <a:t>42 автотеста — запускаются на GitHub при каждом изменении</a:t>
+            </a:r>
+          </a:p>
+          <a:p>
+            <a:pPr algn="l" marL="201168" indent="-201168">
+              <a:spcAft>
+                <a:spcPts val="800"/>
+              </a:spcAft>
+              <a:buChar char="•"/>
+            </a:pPr>
+            <a:r>
+              <a:rPr sz="1200" b="0" i="0">
+                <a:solidFill>
+                  <a:srgbClr val="4A4F62"/>
+                </a:solidFill>
+                <a:latin typeface="Arial Black"/>
+              </a:rPr>
+              <a:t>Раз в неделю робот проверяет все ссылки-источники</a:t>
             </a:r>
           </a:p>
         </p:txBody>
@@ -6384,6 +6401,23 @@
                 <a:latin typeface="Arial Black"/>
               </a:rPr>
               <a:t>Работает офлайн (PWA), ставится на телефон</a:t>
+            </a:r>
+          </a:p>
+          <a:p>
+            <a:pPr algn="l" marL="201168" indent="-201168">
+              <a:spcAft>
+                <a:spcPts val="800"/>
+              </a:spcAft>
+              <a:buChar char="•"/>
+            </a:pPr>
+            <a:r>
+              <a:rPr sz="1200" b="0" i="0">
+                <a:solidFill>
+                  <a:srgbClr val="4A4F62"/>
+                </a:solidFill>
+                <a:latin typeface="Arial Black"/>
+              </a:rPr>
+              <a:t>Русский и қазақша</a:t>
             </a:r>
           </a:p>
           <a:p>
@@ -7715,7 +7749,7 @@
                 </a:solidFill>
                 <a:latin typeface="Arial Black"/>
               </a:rPr>
-              <a:t>Казахский язык · база 100+ возможностей с проверкой модератором · еженедельная автопроверка источников · Telegram-напоминания · режим для профориентатора</a:t>
+              <a:t>Вычитка казахского и перевод описаний · база 100+ возможностей с проверкой модератором · сравнение содержимого страниц-источников · Telegram-напоминания · режим для профориентатора</a:t>
             </a:r>
           </a:p>
         </p:txBody>
@@ -11952,7 +11986,7 @@
                 </a:solidFill>
                 <a:latin typeface="Arial Black"/>
               </a:rPr>
-              <a:t>Когда записаться на IELTS, просить рекомендации, писать эссе. Конфликты дедлайнов — сразу видны.</a:t>
+              <a:t>Когда записаться на IELTS, просить рекомендации, писать эссе. И на годы вперёд: «доступно в 2028» → цель с планом с сегодняшнего дня.</a:t>
             </a:r>
           </a:p>
         </p:txBody>
@@ -12130,7 +12164,7 @@
                 </a:solidFill>
                 <a:latin typeface="Arial Black"/>
               </a:rPr>
-              <a:t>Работает на любом телефоне и без интернета — без установки и регистрации</a:t>
+              <a:t>На любом телефоне и без интернета · без регистрации · русский и қазақша</a:t>
             </a:r>
           </a:p>
         </p:txBody>
@@ -12935,7 +12969,7 @@
                 </a:solidFill>
                 <a:latin typeface="Arial Black"/>
               </a:rPr>
-              <a:t>Сейчас 10 класс. Профиль «переводится» на год вперёд: станет доступно в 2028.</a:t>
+              <a:t>Сейчас 10 класс → «доступно в 2028». Можно сразу сделать это целью: план начинается сегодня.</a:t>
             </a:r>
           </a:p>
         </p:txBody>

</xml_diff>

<commit_message>
Usability test results (n=6) and fixes: clearer average-grade field, 'where exactly' links
Co-Authored-By: Claude Opus 5.5 <noreply@anthropic.com>
</commit_message>
<xml_diff>
--- a/docs/Maqsat_VentureHack2026_Final.pptx
+++ b/docs/Maqsat_VentureHack2026_Final.pptx
@@ -723,7 +723,7 @@
           <a:lstStyle/>
           <a:p>
             <a:r>
-              <a:t>Интервью: школьный профориентатор, завуч, учитель английского, ученик, подававший на FLEX, родитель. Полные ответы — docs/research-plan.md. Подчеркните: изменения сделаны в ту же ночь.</a:t>
+              <a:t>Интервью: школьный профориентатор, завуч, учитель английского, ученик, подававший на FLEX, родитель. Юзабилити-тест: 6 учеников 10–12 класса прошли его на расстоянии через #test, результаты прислали сами (таблица в docs/research-plan.md). Выборка маленькая и без 9 класса — так и говорите. Подчеркните: изменения сделаны в ту же ночь.</a:t>
             </a:r>
           </a:p>
         </p:txBody>
@@ -9985,7 +9985,7 @@
                 </a:solidFill>
                 <a:latin typeface="Arial Black"/>
               </a:rPr>
-              <a:t>ИНТЕРВЬЮ</a:t>
+              <a:t>ИНТЕРВЬЮ И ТЕСТ</a:t>
             </a:r>
           </a:p>
         </p:txBody>
@@ -10020,7 +10020,7 @@
                 </a:solidFill>
                 <a:latin typeface="Arial Black"/>
               </a:rPr>
-              <a:t>5 ЧЕЛОВЕК — И ЧТО МЫ ИЗМЕНИЛИ ЗА НОЧЬ</a:t>
+              <a:t>5 ИНТЕРВЬЮ, 6 УЧЕНИКОВ — И ЧТО МЫ ИЗМЕНИЛИ ЗА НОЧЬ</a:t>
             </a:r>
           </a:p>
         </p:txBody>
@@ -11236,11 +11236,11 @@
             <a:r>
               <a:rPr sz="1100" b="0" i="0">
                 <a:solidFill>
-                  <a:srgbClr val="7A8094"/>
-                </a:solidFill>
-                <a:latin typeface="Arial Black"/>
-              </a:rPr>
-              <a:t>Все пятеро доверяют только данным со ссылкой на источник и датой проверки — это уже было в продукте. «Шансы поступления» и шаблонные эссе нам прямо не советовали делать.</a:t>
+                  <a:srgbClr val="2F3FBF"/>
+                </a:solidFill>
+                <a:latin typeface="Arial Black"/>
+              </a:rPr>
+              <a:t>Юзабилити-тест: 6 учеников (10–12 класс) сами нашли возможность и добавили её в план — медиана 1:31 (от 0:57 до 2:55). 6 из 6 воспользовались бы. 3 из 6 не поняли «средний балл» — исправили.</a:t>
             </a:r>
           </a:p>
         </p:txBody>

</xml_diff>

<commit_message>
Deck: business model slide; README and pitch model section
Co-Authored-By: Claude Opus 5.5 <noreply@anthropic.com>
</commit_message>
<xml_diff>
--- a/docs/Maqsat_VentureHack2026_Final.pptx
+++ b/docs/Maqsat_VentureHack2026_Final.pptx
@@ -17,6 +17,7 @@
     <p:sldId id="265" r:id="rId17"/>
     <p:sldId id="266" r:id="rId18"/>
     <p:sldId id="267" r:id="rId19"/>
+    <p:sldId id="268" r:id="rId20"/>
   </p:sldIdLst>
   <p:sldSz cx="12191695" cy="6858000" type="screen4x3"/>
   <p:notesSz cx="6858000" cy="9144000"/>
@@ -514,6 +515,76 @@
           <a:p>
             <a:r>
               <a:t>Maqsat — по-казахски «цель». Мы помогаем пройти путь от «я где-то слышал о программе» до «заявка отправлена вовремя».</a:t>
+            </a:r>
+          </a:p>
+        </p:txBody>
+      </p:sp>
+      <p:sp>
+        <p:nvSpPr>
+          <p:cNvPr id="4" name="Slide Number Placeholder 3"/>
+          <p:cNvSpPr>
+            <a:spLocks noGrp="1"/>
+          </p:cNvSpPr>
+          <p:nvPr>
+            <p:ph type="sldNum" idx="5" sz="quarter"/>
+          </p:nvPr>
+        </p:nvSpPr>
+        <p:spPr/>
+      </p:sp>
+    </p:spTree>
+  </p:cSld>
+  <p:clrMapOvr>
+    <a:masterClrMapping/>
+  </p:clrMapOvr>
+</p:notes>
+</file>
+
+<file path=ppt/notesSlides/notesSlide10.xml><?xml version="1.0" encoding="utf-8"?>
+<p:notes xmlns:a="http://schemas.openxmlformats.org/drawingml/2006/main" xmlns:p="http://schemas.openxmlformats.org/presentationml/2006/main" xmlns:r="http://schemas.openxmlformats.org/officeDocument/2006/relationships">
+  <p:cSld>
+    <p:spTree>
+      <p:nvGrpSpPr>
+        <p:cNvPr id="1" name=""/>
+        <p:cNvGrpSpPr/>
+        <p:nvPr/>
+      </p:nvGrpSpPr>
+      <p:grpSpPr>
+        <a:xfrm>
+          <a:off x="0" y="0"/>
+          <a:ext cx="0" cy="0"/>
+          <a:chOff x="0" y="0"/>
+          <a:chExt cx="0" cy="0"/>
+        </a:xfrm>
+      </p:grpSpPr>
+      <p:sp>
+        <p:nvSpPr>
+          <p:cNvPr id="2" name="Slide Image Placeholder 1"/>
+          <p:cNvSpPr>
+            <a:spLocks noGrp="1"/>
+          </p:cNvSpPr>
+          <p:nvPr>
+            <p:ph type="sldImg" idx="2"/>
+          </p:nvPr>
+        </p:nvSpPr>
+        <p:spPr/>
+      </p:sp>
+      <p:sp>
+        <p:nvSpPr>
+          <p:cNvPr id="3" name="Notes Placeholder 2"/>
+          <p:cNvSpPr>
+            <a:spLocks noGrp="1"/>
+          </p:cNvSpPr>
+          <p:nvPr>
+            <p:ph type="body" idx="3" sz="quarter"/>
+          </p:nvPr>
+        </p:nvSpPr>
+        <p:spPr/>
+        <p:txBody>
+          <a:bodyPr/>
+          <a:lstStyle/>
+          <a:p>
+            <a:r>
+              <a:t>Главное: ученик никогда не платит и данные не продаются — иначе пропадает доверие. Основная ставка — школы: профориентатору нужно видеть весь класс, а не одного ученика. Цен не называем: их ещё не проверяли. Если спросят «сколько» — «проверим интервью со школами; сначала нужно подтвердить, что за это готовы платить».</a:t>
             </a:r>
           </a:p>
         </p:txBody>
@@ -6502,6 +6573,1191 @@
 <file path=ppt/slides/slide12.xml><?xml version="1.0" encoding="utf-8"?>
 <p:sld xmlns:a="http://schemas.openxmlformats.org/drawingml/2006/main" xmlns:p="http://schemas.openxmlformats.org/presentationml/2006/main" xmlns:r="http://schemas.openxmlformats.org/officeDocument/2006/relationships">
   <p:cSld>
+    <p:bg>
+      <p:bgPr>
+        <a:solidFill>
+          <a:srgbClr val="FFFFFF"/>
+        </a:solidFill>
+        <a:effectLst/>
+      </p:bgPr>
+    </p:bg>
+    <p:spTree>
+      <p:nvGrpSpPr>
+        <p:cNvPr id="1" name=""/>
+        <p:cNvGrpSpPr/>
+        <p:nvPr/>
+      </p:nvGrpSpPr>
+      <p:grpSpPr/>
+      <p:sp>
+        <p:nvSpPr>
+          <p:cNvPr id="2" name="Oval 1"/>
+          <p:cNvSpPr/>
+          <p:nvPr/>
+        </p:nvSpPr>
+        <p:spPr>
+          <a:xfrm>
+            <a:off x="10408615" y="384048"/>
+            <a:ext cx="384048" cy="384048"/>
+          </a:xfrm>
+          <a:prstGeom prst="ellipse">
+            <a:avLst/>
+          </a:prstGeom>
+          <a:noFill/>
+          <a:ln w="25400">
+            <a:solidFill>
+              <a:srgbClr val="2F3FBF"/>
+            </a:solidFill>
+          </a:ln>
+          <a:effectLst/>
+        </p:spPr>
+        <p:style>
+          <a:lnRef idx="1">
+            <a:schemeClr val="accent1"/>
+          </a:lnRef>
+          <a:fillRef idx="3">
+            <a:schemeClr val="accent1"/>
+          </a:fillRef>
+          <a:effectRef idx="2">
+            <a:schemeClr val="accent1"/>
+          </a:effectRef>
+          <a:fontRef idx="minor">
+            <a:schemeClr val="lt1"/>
+          </a:fontRef>
+        </p:style>
+        <p:txBody>
+          <a:bodyPr rtlCol="0" anchor="ctr" lIns="54864" rIns="54864" tIns="18288" bIns="18288"/>
+          <a:lstStyle/>
+          <a:p>
+            <a:pPr algn="ctr"/>
+          </a:p>
+        </p:txBody>
+      </p:sp>
+      <p:sp>
+        <p:nvSpPr>
+          <p:cNvPr id="3" name="Oval 2"/>
+          <p:cNvSpPr/>
+          <p:nvPr/>
+        </p:nvSpPr>
+        <p:spPr>
+          <a:xfrm>
+            <a:off x="10489265" y="464698"/>
+            <a:ext cx="222747" cy="222747"/>
+          </a:xfrm>
+          <a:prstGeom prst="ellipse">
+            <a:avLst/>
+          </a:prstGeom>
+          <a:noFill/>
+          <a:ln w="25400">
+            <a:solidFill>
+              <a:srgbClr val="2F3FBF"/>
+            </a:solidFill>
+          </a:ln>
+          <a:effectLst/>
+        </p:spPr>
+        <p:style>
+          <a:lnRef idx="1">
+            <a:schemeClr val="accent1"/>
+          </a:lnRef>
+          <a:fillRef idx="3">
+            <a:schemeClr val="accent1"/>
+          </a:fillRef>
+          <a:effectRef idx="2">
+            <a:schemeClr val="accent1"/>
+          </a:effectRef>
+          <a:fontRef idx="minor">
+            <a:schemeClr val="lt1"/>
+          </a:fontRef>
+        </p:style>
+        <p:txBody>
+          <a:bodyPr rtlCol="0" anchor="ctr" lIns="54864" rIns="54864" tIns="18288" bIns="18288"/>
+          <a:lstStyle/>
+          <a:p>
+            <a:pPr algn="ctr"/>
+          </a:p>
+        </p:txBody>
+      </p:sp>
+      <p:sp>
+        <p:nvSpPr>
+          <p:cNvPr id="4" name="Oval 3"/>
+          <p:cNvSpPr/>
+          <p:nvPr/>
+        </p:nvSpPr>
+        <p:spPr>
+          <a:xfrm>
+            <a:off x="10562234" y="537667"/>
+            <a:ext cx="76809" cy="76809"/>
+          </a:xfrm>
+          <a:prstGeom prst="ellipse">
+            <a:avLst/>
+          </a:prstGeom>
+          <a:solidFill>
+            <a:srgbClr val="F2A900"/>
+          </a:solidFill>
+          <a:ln>
+            <a:noFill/>
+          </a:ln>
+          <a:effectLst/>
+        </p:spPr>
+        <p:style>
+          <a:lnRef idx="1">
+            <a:schemeClr val="accent1"/>
+          </a:lnRef>
+          <a:fillRef idx="3">
+            <a:schemeClr val="accent1"/>
+          </a:fillRef>
+          <a:effectRef idx="2">
+            <a:schemeClr val="accent1"/>
+          </a:effectRef>
+          <a:fontRef idx="minor">
+            <a:schemeClr val="lt1"/>
+          </a:fontRef>
+        </p:style>
+        <p:txBody>
+          <a:bodyPr rtlCol="0" anchor="ctr" lIns="54864" rIns="54864" tIns="18288" bIns="18288"/>
+          <a:lstStyle/>
+          <a:p>
+            <a:pPr algn="ctr"/>
+          </a:p>
+        </p:txBody>
+      </p:sp>
+      <p:sp>
+        <p:nvSpPr>
+          <p:cNvPr id="5" name="TextBox 4"/>
+          <p:cNvSpPr txBox="1"/>
+          <p:nvPr/>
+        </p:nvSpPr>
+        <p:spPr>
+          <a:xfrm>
+            <a:off x="10884103" y="402336"/>
+            <a:ext cx="1371600" cy="365760"/>
+          </a:xfrm>
+          <a:prstGeom prst="rect">
+            <a:avLst/>
+          </a:prstGeom>
+          <a:noFill/>
+        </p:spPr>
+        <p:txBody>
+          <a:bodyPr wrap="square" lIns="0" rIns="0" tIns="0" bIns="0" anchor="ctr">
+            <a:spAutoFit/>
+          </a:bodyPr>
+          <a:lstStyle/>
+          <a:p>
+            <a:pPr algn="l"/>
+            <a:r>
+              <a:rPr sz="1400" b="0" i="0">
+                <a:solidFill>
+                  <a:srgbClr val="2F3FBF"/>
+                </a:solidFill>
+                <a:latin typeface="Arial Black"/>
+              </a:rPr>
+              <a:t>Maqsat</a:t>
+            </a:r>
+          </a:p>
+        </p:txBody>
+      </p:sp>
+      <p:sp>
+        <p:nvSpPr>
+          <p:cNvPr id="6" name="TextBox 5"/>
+          <p:cNvSpPr txBox="1"/>
+          <p:nvPr/>
+        </p:nvSpPr>
+        <p:spPr>
+          <a:xfrm>
+            <a:off x="640080" y="868680"/>
+            <a:ext cx="10881360" cy="777240"/>
+          </a:xfrm>
+          <a:prstGeom prst="rect">
+            <a:avLst/>
+          </a:prstGeom>
+          <a:noFill/>
+        </p:spPr>
+        <p:txBody>
+          <a:bodyPr wrap="square" lIns="0" rIns="0" tIns="0" bIns="0" anchor="t">
+            <a:spAutoFit/>
+          </a:bodyPr>
+          <a:lstStyle/>
+          <a:p>
+            <a:pPr algn="l"/>
+            <a:r>
+              <a:rPr sz="4400" b="0" i="0">
+                <a:solidFill>
+                  <a:srgbClr val="2F3FBF"/>
+                </a:solidFill>
+                <a:latin typeface="Arial Black"/>
+              </a:rPr>
+              <a:t>МОДЕЛЬ</a:t>
+            </a:r>
+          </a:p>
+        </p:txBody>
+      </p:sp>
+      <p:sp>
+        <p:nvSpPr>
+          <p:cNvPr id="7" name="TextBox 6"/>
+          <p:cNvSpPr txBox="1"/>
+          <p:nvPr/>
+        </p:nvSpPr>
+        <p:spPr>
+          <a:xfrm>
+            <a:off x="640080" y="1618488"/>
+            <a:ext cx="10881360" cy="822960"/>
+          </a:xfrm>
+          <a:prstGeom prst="rect">
+            <a:avLst/>
+          </a:prstGeom>
+          <a:noFill/>
+        </p:spPr>
+        <p:txBody>
+          <a:bodyPr wrap="square" lIns="0" rIns="0" tIns="0" bIns="0" anchor="t">
+            <a:spAutoFit/>
+          </a:bodyPr>
+          <a:lstStyle/>
+          <a:p>
+            <a:pPr algn="l"/>
+            <a:r>
+              <a:rPr sz="2200" b="0" i="0">
+                <a:solidFill>
+                  <a:srgbClr val="111424"/>
+                </a:solidFill>
+                <a:latin typeface="Arial Black"/>
+              </a:rPr>
+              <a:t>УЧЕНИКУ — БЕСПЛАТНО. ПЛАТЯТ ТЕ, КОМУ МЫ ЭКОНОМИМ ВРЕМЯ</a:t>
+            </a:r>
+          </a:p>
+        </p:txBody>
+      </p:sp>
+      <p:sp>
+        <p:nvSpPr>
+          <p:cNvPr id="8" name="Rectangle 7"/>
+          <p:cNvSpPr/>
+          <p:nvPr/>
+        </p:nvSpPr>
+        <p:spPr>
+          <a:xfrm>
+            <a:off x="640080" y="2240280"/>
+            <a:ext cx="3474720" cy="2788920"/>
+          </a:xfrm>
+          <a:prstGeom prst="rect">
+            <a:avLst/>
+          </a:prstGeom>
+          <a:solidFill>
+            <a:srgbClr val="F6F7FB"/>
+          </a:solidFill>
+          <a:ln>
+            <a:noFill/>
+          </a:ln>
+          <a:effectLst/>
+        </p:spPr>
+        <p:style>
+          <a:lnRef idx="1">
+            <a:schemeClr val="accent1"/>
+          </a:lnRef>
+          <a:fillRef idx="3">
+            <a:schemeClr val="accent1"/>
+          </a:fillRef>
+          <a:effectRef idx="2">
+            <a:schemeClr val="accent1"/>
+          </a:effectRef>
+          <a:fontRef idx="minor">
+            <a:schemeClr val="lt1"/>
+          </a:fontRef>
+        </p:style>
+        <p:txBody>
+          <a:bodyPr rtlCol="0" anchor="ctr" lIns="54864" rIns="54864" tIns="18288" bIns="18288"/>
+          <a:lstStyle/>
+          <a:p>
+            <a:pPr algn="ctr"/>
+          </a:p>
+        </p:txBody>
+      </p:sp>
+      <p:sp>
+        <p:nvSpPr>
+          <p:cNvPr id="9" name="Oval 8"/>
+          <p:cNvSpPr/>
+          <p:nvPr/>
+        </p:nvSpPr>
+        <p:spPr>
+          <a:xfrm>
+            <a:off x="914400" y="2468880"/>
+            <a:ext cx="457200" cy="457200"/>
+          </a:xfrm>
+          <a:prstGeom prst="ellipse">
+            <a:avLst/>
+          </a:prstGeom>
+          <a:noFill/>
+          <a:ln w="25400">
+            <a:solidFill>
+              <a:srgbClr val="2F3FBF"/>
+            </a:solidFill>
+          </a:ln>
+          <a:effectLst/>
+        </p:spPr>
+        <p:style>
+          <a:lnRef idx="1">
+            <a:schemeClr val="accent1"/>
+          </a:lnRef>
+          <a:fillRef idx="3">
+            <a:schemeClr val="accent1"/>
+          </a:fillRef>
+          <a:effectRef idx="2">
+            <a:schemeClr val="accent1"/>
+          </a:effectRef>
+          <a:fontRef idx="minor">
+            <a:schemeClr val="lt1"/>
+          </a:fontRef>
+        </p:style>
+        <p:txBody>
+          <a:bodyPr rtlCol="0" anchor="ctr" lIns="54864" rIns="54864" tIns="18288" bIns="18288"/>
+          <a:lstStyle/>
+          <a:p>
+            <a:pPr algn="ctr"/>
+          </a:p>
+        </p:txBody>
+      </p:sp>
+      <p:sp>
+        <p:nvSpPr>
+          <p:cNvPr id="10" name="Oval 9"/>
+          <p:cNvSpPr/>
+          <p:nvPr/>
+        </p:nvSpPr>
+        <p:spPr>
+          <a:xfrm>
+            <a:off x="1010412" y="2564892"/>
+            <a:ext cx="265176" cy="265176"/>
+          </a:xfrm>
+          <a:prstGeom prst="ellipse">
+            <a:avLst/>
+          </a:prstGeom>
+          <a:noFill/>
+          <a:ln w="25400">
+            <a:solidFill>
+              <a:srgbClr val="2F3FBF"/>
+            </a:solidFill>
+          </a:ln>
+          <a:effectLst/>
+        </p:spPr>
+        <p:style>
+          <a:lnRef idx="1">
+            <a:schemeClr val="accent1"/>
+          </a:lnRef>
+          <a:fillRef idx="3">
+            <a:schemeClr val="accent1"/>
+          </a:fillRef>
+          <a:effectRef idx="2">
+            <a:schemeClr val="accent1"/>
+          </a:effectRef>
+          <a:fontRef idx="minor">
+            <a:schemeClr val="lt1"/>
+          </a:fontRef>
+        </p:style>
+        <p:txBody>
+          <a:bodyPr rtlCol="0" anchor="ctr" lIns="54864" rIns="54864" tIns="18288" bIns="18288"/>
+          <a:lstStyle/>
+          <a:p>
+            <a:pPr algn="ctr"/>
+          </a:p>
+        </p:txBody>
+      </p:sp>
+      <p:sp>
+        <p:nvSpPr>
+          <p:cNvPr id="11" name="Oval 10"/>
+          <p:cNvSpPr/>
+          <p:nvPr/>
+        </p:nvSpPr>
+        <p:spPr>
+          <a:xfrm>
+            <a:off x="1097280" y="2651760"/>
+            <a:ext cx="91440" cy="91440"/>
+          </a:xfrm>
+          <a:prstGeom prst="ellipse">
+            <a:avLst/>
+          </a:prstGeom>
+          <a:solidFill>
+            <a:srgbClr val="F2A900"/>
+          </a:solidFill>
+          <a:ln>
+            <a:noFill/>
+          </a:ln>
+          <a:effectLst/>
+        </p:spPr>
+        <p:style>
+          <a:lnRef idx="1">
+            <a:schemeClr val="accent1"/>
+          </a:lnRef>
+          <a:fillRef idx="3">
+            <a:schemeClr val="accent1"/>
+          </a:fillRef>
+          <a:effectRef idx="2">
+            <a:schemeClr val="accent1"/>
+          </a:effectRef>
+          <a:fontRef idx="minor">
+            <a:schemeClr val="lt1"/>
+          </a:fontRef>
+        </p:style>
+        <p:txBody>
+          <a:bodyPr rtlCol="0" anchor="ctr" lIns="54864" rIns="54864" tIns="18288" bIns="18288"/>
+          <a:lstStyle/>
+          <a:p>
+            <a:pPr algn="ctr"/>
+          </a:p>
+        </p:txBody>
+      </p:sp>
+      <p:sp>
+        <p:nvSpPr>
+          <p:cNvPr id="12" name="TextBox 11"/>
+          <p:cNvSpPr txBox="1"/>
+          <p:nvPr/>
+        </p:nvSpPr>
+        <p:spPr>
+          <a:xfrm>
+            <a:off x="960119" y="3108960"/>
+            <a:ext cx="2926080" cy="320040"/>
+          </a:xfrm>
+          <a:prstGeom prst="rect">
+            <a:avLst/>
+          </a:prstGeom>
+          <a:noFill/>
+        </p:spPr>
+        <p:txBody>
+          <a:bodyPr wrap="square" lIns="0" rIns="0" tIns="0" bIns="0" anchor="t">
+            <a:spAutoFit/>
+          </a:bodyPr>
+          <a:lstStyle/>
+          <a:p>
+            <a:pPr algn="l"/>
+            <a:r>
+              <a:rPr sz="1100" b="0" i="0">
+                <a:solidFill>
+                  <a:srgbClr val="7A8094"/>
+                </a:solidFill>
+                <a:latin typeface="Arial Black"/>
+              </a:rPr>
+              <a:t>УЧЕНИК И РОДИТЕЛЬ</a:t>
+            </a:r>
+          </a:p>
+        </p:txBody>
+      </p:sp>
+      <p:sp>
+        <p:nvSpPr>
+          <p:cNvPr id="13" name="TextBox 12"/>
+          <p:cNvSpPr txBox="1"/>
+          <p:nvPr/>
+        </p:nvSpPr>
+        <p:spPr>
+          <a:xfrm>
+            <a:off x="960119" y="3429000"/>
+            <a:ext cx="2926080" cy="457200"/>
+          </a:xfrm>
+          <a:prstGeom prst="rect">
+            <a:avLst/>
+          </a:prstGeom>
+          <a:noFill/>
+        </p:spPr>
+        <p:txBody>
+          <a:bodyPr wrap="square" lIns="0" rIns="0" tIns="0" bIns="0" anchor="t">
+            <a:spAutoFit/>
+          </a:bodyPr>
+          <a:lstStyle/>
+          <a:p>
+            <a:pPr algn="l"/>
+            <a:r>
+              <a:rPr sz="1800" b="0" i="0">
+                <a:solidFill>
+                  <a:srgbClr val="2F3FBF"/>
+                </a:solidFill>
+                <a:latin typeface="Arial Black"/>
+              </a:rPr>
+              <a:t>Бесплатно</a:t>
+            </a:r>
+          </a:p>
+        </p:txBody>
+      </p:sp>
+      <p:sp>
+        <p:nvSpPr>
+          <p:cNvPr id="14" name="TextBox 13"/>
+          <p:cNvSpPr txBox="1"/>
+          <p:nvPr/>
+        </p:nvSpPr>
+        <p:spPr>
+          <a:xfrm>
+            <a:off x="960119" y="3931920"/>
+            <a:ext cx="2926080" cy="1097280"/>
+          </a:xfrm>
+          <a:prstGeom prst="rect">
+            <a:avLst/>
+          </a:prstGeom>
+          <a:noFill/>
+        </p:spPr>
+        <p:txBody>
+          <a:bodyPr wrap="square" lIns="0" rIns="0" tIns="0" bIns="0" anchor="t">
+            <a:spAutoFit/>
+          </a:bodyPr>
+          <a:lstStyle/>
+          <a:p>
+            <a:pPr algn="l"/>
+            <a:r>
+              <a:rPr sz="1100" b="0" i="0">
+                <a:solidFill>
+                  <a:srgbClr val="4A4F62"/>
+                </a:solidFill>
+                <a:latin typeface="Arial Black"/>
+              </a:rPr>
+              <a:t>Подбор, план, календарь — всегда бесплатно. Без рекламы и продажи данных: профиль и так не покидает телефон.</a:t>
+            </a:r>
+          </a:p>
+        </p:txBody>
+      </p:sp>
+      <p:sp>
+        <p:nvSpPr>
+          <p:cNvPr id="15" name="Rectangle 14"/>
+          <p:cNvSpPr/>
+          <p:nvPr/>
+        </p:nvSpPr>
+        <p:spPr>
+          <a:xfrm>
+            <a:off x="4343400" y="2240280"/>
+            <a:ext cx="3474720" cy="2788920"/>
+          </a:xfrm>
+          <a:prstGeom prst="rect">
+            <a:avLst/>
+          </a:prstGeom>
+          <a:solidFill>
+            <a:srgbClr val="2F3FBF"/>
+          </a:solidFill>
+          <a:ln>
+            <a:noFill/>
+          </a:ln>
+          <a:effectLst/>
+        </p:spPr>
+        <p:style>
+          <a:lnRef idx="1">
+            <a:schemeClr val="accent1"/>
+          </a:lnRef>
+          <a:fillRef idx="3">
+            <a:schemeClr val="accent1"/>
+          </a:fillRef>
+          <a:effectRef idx="2">
+            <a:schemeClr val="accent1"/>
+          </a:effectRef>
+          <a:fontRef idx="minor">
+            <a:schemeClr val="lt1"/>
+          </a:fontRef>
+        </p:style>
+        <p:txBody>
+          <a:bodyPr rtlCol="0" anchor="ctr" lIns="54864" rIns="54864" tIns="18288" bIns="18288"/>
+          <a:lstStyle/>
+          <a:p>
+            <a:pPr algn="ctr"/>
+          </a:p>
+        </p:txBody>
+      </p:sp>
+      <p:sp>
+        <p:nvSpPr>
+          <p:cNvPr id="16" name="Oval 15"/>
+          <p:cNvSpPr/>
+          <p:nvPr/>
+        </p:nvSpPr>
+        <p:spPr>
+          <a:xfrm>
+            <a:off x="4617720" y="2468880"/>
+            <a:ext cx="457200" cy="457200"/>
+          </a:xfrm>
+          <a:prstGeom prst="ellipse">
+            <a:avLst/>
+          </a:prstGeom>
+          <a:noFill/>
+          <a:ln w="25400">
+            <a:solidFill>
+              <a:srgbClr val="FFFFFF"/>
+            </a:solidFill>
+          </a:ln>
+          <a:effectLst/>
+        </p:spPr>
+        <p:style>
+          <a:lnRef idx="1">
+            <a:schemeClr val="accent1"/>
+          </a:lnRef>
+          <a:fillRef idx="3">
+            <a:schemeClr val="accent1"/>
+          </a:fillRef>
+          <a:effectRef idx="2">
+            <a:schemeClr val="accent1"/>
+          </a:effectRef>
+          <a:fontRef idx="minor">
+            <a:schemeClr val="lt1"/>
+          </a:fontRef>
+        </p:style>
+        <p:txBody>
+          <a:bodyPr rtlCol="0" anchor="ctr" lIns="54864" rIns="54864" tIns="18288" bIns="18288"/>
+          <a:lstStyle/>
+          <a:p>
+            <a:pPr algn="ctr"/>
+          </a:p>
+        </p:txBody>
+      </p:sp>
+      <p:sp>
+        <p:nvSpPr>
+          <p:cNvPr id="17" name="Oval 16"/>
+          <p:cNvSpPr/>
+          <p:nvPr/>
+        </p:nvSpPr>
+        <p:spPr>
+          <a:xfrm>
+            <a:off x="4713732" y="2564892"/>
+            <a:ext cx="265176" cy="265176"/>
+          </a:xfrm>
+          <a:prstGeom prst="ellipse">
+            <a:avLst/>
+          </a:prstGeom>
+          <a:noFill/>
+          <a:ln w="25400">
+            <a:solidFill>
+              <a:srgbClr val="FFFFFF"/>
+            </a:solidFill>
+          </a:ln>
+          <a:effectLst/>
+        </p:spPr>
+        <p:style>
+          <a:lnRef idx="1">
+            <a:schemeClr val="accent1"/>
+          </a:lnRef>
+          <a:fillRef idx="3">
+            <a:schemeClr val="accent1"/>
+          </a:fillRef>
+          <a:effectRef idx="2">
+            <a:schemeClr val="accent1"/>
+          </a:effectRef>
+          <a:fontRef idx="minor">
+            <a:schemeClr val="lt1"/>
+          </a:fontRef>
+        </p:style>
+        <p:txBody>
+          <a:bodyPr rtlCol="0" anchor="ctr" lIns="54864" rIns="54864" tIns="18288" bIns="18288"/>
+          <a:lstStyle/>
+          <a:p>
+            <a:pPr algn="ctr"/>
+          </a:p>
+        </p:txBody>
+      </p:sp>
+      <p:sp>
+        <p:nvSpPr>
+          <p:cNvPr id="18" name="Oval 17"/>
+          <p:cNvSpPr/>
+          <p:nvPr/>
+        </p:nvSpPr>
+        <p:spPr>
+          <a:xfrm>
+            <a:off x="4800600" y="2651760"/>
+            <a:ext cx="91440" cy="91440"/>
+          </a:xfrm>
+          <a:prstGeom prst="ellipse">
+            <a:avLst/>
+          </a:prstGeom>
+          <a:solidFill>
+            <a:srgbClr val="F2A900"/>
+          </a:solidFill>
+          <a:ln>
+            <a:noFill/>
+          </a:ln>
+          <a:effectLst/>
+        </p:spPr>
+        <p:style>
+          <a:lnRef idx="1">
+            <a:schemeClr val="accent1"/>
+          </a:lnRef>
+          <a:fillRef idx="3">
+            <a:schemeClr val="accent1"/>
+          </a:fillRef>
+          <a:effectRef idx="2">
+            <a:schemeClr val="accent1"/>
+          </a:effectRef>
+          <a:fontRef idx="minor">
+            <a:schemeClr val="lt1"/>
+          </a:fontRef>
+        </p:style>
+        <p:txBody>
+          <a:bodyPr rtlCol="0" anchor="ctr" lIns="54864" rIns="54864" tIns="18288" bIns="18288"/>
+          <a:lstStyle/>
+          <a:p>
+            <a:pPr algn="ctr"/>
+          </a:p>
+        </p:txBody>
+      </p:sp>
+      <p:sp>
+        <p:nvSpPr>
+          <p:cNvPr id="19" name="TextBox 18"/>
+          <p:cNvSpPr txBox="1"/>
+          <p:nvPr/>
+        </p:nvSpPr>
+        <p:spPr>
+          <a:xfrm>
+            <a:off x="4663440" y="3108960"/>
+            <a:ext cx="2926080" cy="320040"/>
+          </a:xfrm>
+          <a:prstGeom prst="rect">
+            <a:avLst/>
+          </a:prstGeom>
+          <a:noFill/>
+        </p:spPr>
+        <p:txBody>
+          <a:bodyPr wrap="square" lIns="0" rIns="0" tIns="0" bIns="0" anchor="t">
+            <a:spAutoFit/>
+          </a:bodyPr>
+          <a:lstStyle/>
+          <a:p>
+            <a:pPr algn="l"/>
+            <a:r>
+              <a:rPr sz="1100" b="0" i="0">
+                <a:solidFill>
+                  <a:srgbClr val="C3C9F4"/>
+                </a:solidFill>
+                <a:latin typeface="Arial Black"/>
+              </a:rPr>
+              <a:t>ШКОЛЫ И УЧЕБНЫЕ ЦЕНТРЫ</a:t>
+            </a:r>
+          </a:p>
+        </p:txBody>
+      </p:sp>
+      <p:sp>
+        <p:nvSpPr>
+          <p:cNvPr id="20" name="TextBox 19"/>
+          <p:cNvSpPr txBox="1"/>
+          <p:nvPr/>
+        </p:nvSpPr>
+        <p:spPr>
+          <a:xfrm>
+            <a:off x="4663440" y="3429000"/>
+            <a:ext cx="2926080" cy="457200"/>
+          </a:xfrm>
+          <a:prstGeom prst="rect">
+            <a:avLst/>
+          </a:prstGeom>
+          <a:noFill/>
+        </p:spPr>
+        <p:txBody>
+          <a:bodyPr wrap="square" lIns="0" rIns="0" tIns="0" bIns="0" anchor="t">
+            <a:spAutoFit/>
+          </a:bodyPr>
+          <a:lstStyle/>
+          <a:p>
+            <a:pPr algn="l"/>
+            <a:r>
+              <a:rPr sz="1800" b="0" i="0">
+                <a:solidFill>
+                  <a:srgbClr val="FFFFFF"/>
+                </a:solidFill>
+                <a:latin typeface="Arial Black"/>
+              </a:rPr>
+              <a:t>Подписка</a:t>
+            </a:r>
+          </a:p>
+        </p:txBody>
+      </p:sp>
+      <p:sp>
+        <p:nvSpPr>
+          <p:cNvPr id="21" name="TextBox 20"/>
+          <p:cNvSpPr txBox="1"/>
+          <p:nvPr/>
+        </p:nvSpPr>
+        <p:spPr>
+          <a:xfrm>
+            <a:off x="4663440" y="3931920"/>
+            <a:ext cx="2926080" cy="1097280"/>
+          </a:xfrm>
+          <a:prstGeom prst="rect">
+            <a:avLst/>
+          </a:prstGeom>
+          <a:noFill/>
+        </p:spPr>
+        <p:txBody>
+          <a:bodyPr wrap="square" lIns="0" rIns="0" tIns="0" bIns="0" anchor="t">
+            <a:spAutoFit/>
+          </a:bodyPr>
+          <a:lstStyle/>
+          <a:p>
+            <a:pPr algn="l"/>
+            <a:r>
+              <a:rPr sz="1100" b="0" i="0">
+                <a:solidFill>
+                  <a:srgbClr val="FFFFFF"/>
+                </a:solidFill>
+                <a:latin typeface="Arial Black"/>
+              </a:rPr>
+              <a:t>Режим профориентатора: весь класс на одном экране — кто на какую программу идёт, кому нужна рекомендация от школы, у кого горит срок.</a:t>
+            </a:r>
+          </a:p>
+        </p:txBody>
+      </p:sp>
+      <p:sp>
+        <p:nvSpPr>
+          <p:cNvPr id="22" name="Rectangle 21"/>
+          <p:cNvSpPr/>
+          <p:nvPr/>
+        </p:nvSpPr>
+        <p:spPr>
+          <a:xfrm>
+            <a:off x="8046719" y="2240280"/>
+            <a:ext cx="3474720" cy="2788920"/>
+          </a:xfrm>
+          <a:prstGeom prst="rect">
+            <a:avLst/>
+          </a:prstGeom>
+          <a:solidFill>
+            <a:srgbClr val="F6F7FB"/>
+          </a:solidFill>
+          <a:ln>
+            <a:noFill/>
+          </a:ln>
+          <a:effectLst/>
+        </p:spPr>
+        <p:style>
+          <a:lnRef idx="1">
+            <a:schemeClr val="accent1"/>
+          </a:lnRef>
+          <a:fillRef idx="3">
+            <a:schemeClr val="accent1"/>
+          </a:fillRef>
+          <a:effectRef idx="2">
+            <a:schemeClr val="accent1"/>
+          </a:effectRef>
+          <a:fontRef idx="minor">
+            <a:schemeClr val="lt1"/>
+          </a:fontRef>
+        </p:style>
+        <p:txBody>
+          <a:bodyPr rtlCol="0" anchor="ctr" lIns="54864" rIns="54864" tIns="18288" bIns="18288"/>
+          <a:lstStyle/>
+          <a:p>
+            <a:pPr algn="ctr"/>
+          </a:p>
+        </p:txBody>
+      </p:sp>
+      <p:sp>
+        <p:nvSpPr>
+          <p:cNvPr id="23" name="Oval 22"/>
+          <p:cNvSpPr/>
+          <p:nvPr/>
+        </p:nvSpPr>
+        <p:spPr>
+          <a:xfrm>
+            <a:off x="8321040" y="2468880"/>
+            <a:ext cx="457200" cy="457200"/>
+          </a:xfrm>
+          <a:prstGeom prst="ellipse">
+            <a:avLst/>
+          </a:prstGeom>
+          <a:noFill/>
+          <a:ln w="25400">
+            <a:solidFill>
+              <a:srgbClr val="2F3FBF"/>
+            </a:solidFill>
+          </a:ln>
+          <a:effectLst/>
+        </p:spPr>
+        <p:style>
+          <a:lnRef idx="1">
+            <a:schemeClr val="accent1"/>
+          </a:lnRef>
+          <a:fillRef idx="3">
+            <a:schemeClr val="accent1"/>
+          </a:fillRef>
+          <a:effectRef idx="2">
+            <a:schemeClr val="accent1"/>
+          </a:effectRef>
+          <a:fontRef idx="minor">
+            <a:schemeClr val="lt1"/>
+          </a:fontRef>
+        </p:style>
+        <p:txBody>
+          <a:bodyPr rtlCol="0" anchor="ctr" lIns="54864" rIns="54864" tIns="18288" bIns="18288"/>
+          <a:lstStyle/>
+          <a:p>
+            <a:pPr algn="ctr"/>
+          </a:p>
+        </p:txBody>
+      </p:sp>
+      <p:sp>
+        <p:nvSpPr>
+          <p:cNvPr id="24" name="Oval 23"/>
+          <p:cNvSpPr/>
+          <p:nvPr/>
+        </p:nvSpPr>
+        <p:spPr>
+          <a:xfrm>
+            <a:off x="8417052" y="2564892"/>
+            <a:ext cx="265176" cy="265176"/>
+          </a:xfrm>
+          <a:prstGeom prst="ellipse">
+            <a:avLst/>
+          </a:prstGeom>
+          <a:noFill/>
+          <a:ln w="25400">
+            <a:solidFill>
+              <a:srgbClr val="2F3FBF"/>
+            </a:solidFill>
+          </a:ln>
+          <a:effectLst/>
+        </p:spPr>
+        <p:style>
+          <a:lnRef idx="1">
+            <a:schemeClr val="accent1"/>
+          </a:lnRef>
+          <a:fillRef idx="3">
+            <a:schemeClr val="accent1"/>
+          </a:fillRef>
+          <a:effectRef idx="2">
+            <a:schemeClr val="accent1"/>
+          </a:effectRef>
+          <a:fontRef idx="minor">
+            <a:schemeClr val="lt1"/>
+          </a:fontRef>
+        </p:style>
+        <p:txBody>
+          <a:bodyPr rtlCol="0" anchor="ctr" lIns="54864" rIns="54864" tIns="18288" bIns="18288"/>
+          <a:lstStyle/>
+          <a:p>
+            <a:pPr algn="ctr"/>
+          </a:p>
+        </p:txBody>
+      </p:sp>
+      <p:sp>
+        <p:nvSpPr>
+          <p:cNvPr id="25" name="Oval 24"/>
+          <p:cNvSpPr/>
+          <p:nvPr/>
+        </p:nvSpPr>
+        <p:spPr>
+          <a:xfrm>
+            <a:off x="8503919" y="2651760"/>
+            <a:ext cx="91440" cy="91440"/>
+          </a:xfrm>
+          <a:prstGeom prst="ellipse">
+            <a:avLst/>
+          </a:prstGeom>
+          <a:solidFill>
+            <a:srgbClr val="F2A900"/>
+          </a:solidFill>
+          <a:ln>
+            <a:noFill/>
+          </a:ln>
+          <a:effectLst/>
+        </p:spPr>
+        <p:style>
+          <a:lnRef idx="1">
+            <a:schemeClr val="accent1"/>
+          </a:lnRef>
+          <a:fillRef idx="3">
+            <a:schemeClr val="accent1"/>
+          </a:fillRef>
+          <a:effectRef idx="2">
+            <a:schemeClr val="accent1"/>
+          </a:effectRef>
+          <a:fontRef idx="minor">
+            <a:schemeClr val="lt1"/>
+          </a:fontRef>
+        </p:style>
+        <p:txBody>
+          <a:bodyPr rtlCol="0" anchor="ctr" lIns="54864" rIns="54864" tIns="18288" bIns="18288"/>
+          <a:lstStyle/>
+          <a:p>
+            <a:pPr algn="ctr"/>
+          </a:p>
+        </p:txBody>
+      </p:sp>
+      <p:sp>
+        <p:nvSpPr>
+          <p:cNvPr id="26" name="TextBox 25"/>
+          <p:cNvSpPr txBox="1"/>
+          <p:nvPr/>
+        </p:nvSpPr>
+        <p:spPr>
+          <a:xfrm>
+            <a:off x="8366759" y="3108960"/>
+            <a:ext cx="2926080" cy="320040"/>
+          </a:xfrm>
+          <a:prstGeom prst="rect">
+            <a:avLst/>
+          </a:prstGeom>
+          <a:noFill/>
+        </p:spPr>
+        <p:txBody>
+          <a:bodyPr wrap="square" lIns="0" rIns="0" tIns="0" bIns="0" anchor="t">
+            <a:spAutoFit/>
+          </a:bodyPr>
+          <a:lstStyle/>
+          <a:p>
+            <a:pPr algn="l"/>
+            <a:r>
+              <a:rPr sz="1100" b="0" i="0">
+                <a:solidFill>
+                  <a:srgbClr val="7A8094"/>
+                </a:solidFill>
+                <a:latin typeface="Arial Black"/>
+              </a:rPr>
+              <a:t>ОРГАНИЗАТОРЫ ПРОГРАММ</a:t>
+            </a:r>
+          </a:p>
+        </p:txBody>
+      </p:sp>
+      <p:sp>
+        <p:nvSpPr>
+          <p:cNvPr id="27" name="TextBox 26"/>
+          <p:cNvSpPr txBox="1"/>
+          <p:nvPr/>
+        </p:nvSpPr>
+        <p:spPr>
+          <a:xfrm>
+            <a:off x="8366759" y="3429000"/>
+            <a:ext cx="2926080" cy="457200"/>
+          </a:xfrm>
+          <a:prstGeom prst="rect">
+            <a:avLst/>
+          </a:prstGeom>
+          <a:noFill/>
+        </p:spPr>
+        <p:txBody>
+          <a:bodyPr wrap="square" lIns="0" rIns="0" tIns="0" bIns="0" anchor="t">
+            <a:spAutoFit/>
+          </a:bodyPr>
+          <a:lstStyle/>
+          <a:p>
+            <a:pPr algn="l"/>
+            <a:r>
+              <a:rPr sz="1800" b="0" i="0">
+                <a:solidFill>
+                  <a:srgbClr val="2F3FBF"/>
+                </a:solidFill>
+                <a:latin typeface="Arial Black"/>
+              </a:rPr>
+              <a:t>Размещение</a:t>
+            </a:r>
+          </a:p>
+        </p:txBody>
+      </p:sp>
+      <p:sp>
+        <p:nvSpPr>
+          <p:cNvPr id="28" name="TextBox 27"/>
+          <p:cNvSpPr txBox="1"/>
+          <p:nvPr/>
+        </p:nvSpPr>
+        <p:spPr>
+          <a:xfrm>
+            <a:off x="8366759" y="3931920"/>
+            <a:ext cx="2926080" cy="1097280"/>
+          </a:xfrm>
+          <a:prstGeom prst="rect">
+            <a:avLst/>
+          </a:prstGeom>
+          <a:noFill/>
+        </p:spPr>
+        <p:txBody>
+          <a:bodyPr wrap="square" lIns="0" rIns="0" tIns="0" bIns="0" anchor="t">
+            <a:spAutoFit/>
+          </a:bodyPr>
+          <a:lstStyle/>
+          <a:p>
+            <a:pPr algn="l"/>
+            <a:r>
+              <a:rPr sz="1100" b="0" i="0">
+                <a:solidFill>
+                  <a:srgbClr val="4A4F62"/>
+                </a:solidFill>
+                <a:latin typeface="Arial Black"/>
+              </a:rPr>
+              <a:t>Проверенная карточка программы с обязательной ссылкой на источник. Оплата не влияет на статус «подходишь» и помечается словом «партнёр».</a:t>
+            </a:r>
+          </a:p>
+        </p:txBody>
+      </p:sp>
+      <p:sp>
+        <p:nvSpPr>
+          <p:cNvPr id="29" name="TextBox 28"/>
+          <p:cNvSpPr txBox="1"/>
+          <p:nvPr/>
+        </p:nvSpPr>
+        <p:spPr>
+          <a:xfrm>
+            <a:off x="640080" y="5257800"/>
+            <a:ext cx="10881360" cy="365760"/>
+          </a:xfrm>
+          <a:prstGeom prst="rect">
+            <a:avLst/>
+          </a:prstGeom>
+          <a:noFill/>
+        </p:spPr>
+        <p:txBody>
+          <a:bodyPr wrap="square" lIns="0" rIns="0" tIns="0" bIns="0" anchor="t">
+            <a:spAutoFit/>
+          </a:bodyPr>
+          <a:lstStyle/>
+          <a:p>
+            <a:pPr algn="l"/>
+            <a:r>
+              <a:rPr sz="1100" b="0" i="0">
+                <a:solidFill>
+                  <a:srgbClr val="2F3FBF"/>
+                </a:solidFill>
+                <a:latin typeface="Arial Black"/>
+              </a:rPr>
+              <a:t>Расходы сейчас: </a:t>
+            </a:r>
+            <a:r>
+              <a:rPr sz="1100" b="0" i="0">
+                <a:solidFill>
+                  <a:srgbClr val="111424"/>
+                </a:solidFill>
+                <a:latin typeface="Arial Black"/>
+              </a:rPr>
+              <a:t>хостинг — 0 ₸ (статический сайт на GitHub Pages). Главная статья при росте — люди, которые проверяют карточки по первоисточникам.</a:t>
+            </a:r>
+          </a:p>
+        </p:txBody>
+      </p:sp>
+      <p:sp>
+        <p:nvSpPr>
+          <p:cNvPr id="30" name="TextBox 29"/>
+          <p:cNvSpPr txBox="1"/>
+          <p:nvPr/>
+        </p:nvSpPr>
+        <p:spPr>
+          <a:xfrm>
+            <a:off x="640080" y="5806440"/>
+            <a:ext cx="10881360" cy="365760"/>
+          </a:xfrm>
+          <a:prstGeom prst="rect">
+            <a:avLst/>
+          </a:prstGeom>
+          <a:noFill/>
+        </p:spPr>
+        <p:txBody>
+          <a:bodyPr wrap="square" lIns="0" rIns="0" tIns="0" bIns="0" anchor="t">
+            <a:spAutoFit/>
+          </a:bodyPr>
+          <a:lstStyle/>
+          <a:p>
+            <a:pPr algn="l"/>
+            <a:r>
+              <a:rPr sz="1100" b="0" i="0">
+                <a:solidFill>
+                  <a:srgbClr val="7A8094"/>
+                </a:solidFill>
+                <a:latin typeface="Arial Black"/>
+              </a:rPr>
+              <a:t>Это гипотезы. Следующий шаг — интервью со школами и учебными центрами: готовы ли платить, сколько и за что именно.</a:t>
+            </a:r>
+          </a:p>
+        </p:txBody>
+      </p:sp>
+    </p:spTree>
+  </p:cSld>
+  <p:clrMapOvr>
+    <a:masterClrMapping/>
+  </p:clrMapOvr>
+</p:sld>
+</file>
+
+<file path=ppt/slides/slide13.xml><?xml version="1.0" encoding="utf-8"?>
+<p:sld xmlns:a="http://schemas.openxmlformats.org/drawingml/2006/main" xmlns:p="http://schemas.openxmlformats.org/presentationml/2006/main" xmlns:r="http://schemas.openxmlformats.org/officeDocument/2006/relationships">
+  <p:cSld>
     <p:spTree>
       <p:nvGrpSpPr>
         <p:cNvPr id="1" name=""/>
@@ -7503,7 +8759,7 @@
                 </a:solidFill>
                 <a:latin typeface="Arial Black"/>
               </a:rPr>
-              <a:t>до готового плана</a:t>
+              <a:t>до цели · в тесте 1:31</a:t>
             </a:r>
           </a:p>
         </p:txBody>

</xml_diff>